<commit_message>
docs: fan plan, LED power scenario B, wiring and ESC drawing fixes
- Cooling: services stay enabled; 3010 square fan in a shroud at the stack
  end (partner build), blower as backup; airflow model at 2 mm gaps
- LED strip: scenario B chosen - own 5 V buck off the battery feeds strip
  and fan, data through a 74HCT125; ring order from the arm nearest the
  pads; 60 LED/m, 26 AWG silicone wire
- HARDWARE.md: power tree, J2 stays empty, LED pads behind VREG OUT
- Board drawing: ESC underside mirroring fixed (LED pads rear-left, behind
  the VREG pads); scenario B block; airframe drawing and slides updated
- Investigation report: airflow model, partner build, LED supply voltage,
  Sim Lim sourcing, power scenarios, LED pad position

Co-Authored-By: Claude Opus 5.5 <noreply@anthropic.com>
</commit_message>
<xml_diff>
--- a/pictures/slides/starling-2-max-diagrams.pptx
+++ b/pictures/slides/starling-2-max-diagrams.pptx
@@ -3276,8 +3276,8 @@
         </p:blipFill>
         <p:spPr>
           <a:xfrm>
-            <a:off x="1337388" y="0"/>
-            <a:ext cx="9517224" cy="6858000"/>
+            <a:off x="1478733" y="0"/>
+            <a:ext cx="9234534" cy="6858000"/>
           </a:xfrm>
           <a:prstGeom prst="rect">
             <a:avLst/>

</xml_diff>